<commit_message>
Regenerate PPTX with validated Jira numbers
</commit_message>
<xml_diff>
--- a/retro_109_presentation.pptx
+++ b/retro_109_presentation.pptx
@@ -6246,7 +6246,7 @@
                         </a:defRPr>
                       </a:pPr>
                       <a:r>
-                        <a:t>Same issue, Nils 16→47</a:t>
+                        <a:t>Same issue, Nils 16→60</a:t>
                       </a:r>
                     </a:p>
                   </a:txBody>
@@ -6388,7 +6388,7 @@
                         </a:defRPr>
                       </a:pPr>
                       <a:r>
-                        <a:t>Rate dropped 32%→12.6%</a:t>
+                        <a:t>Rate dropped significantly</a:t>
                       </a:r>
                     </a:p>
                   </a:txBody>
@@ -7283,7 +7283,7 @@
                         </a:defRPr>
                       </a:pPr>
                       <a:r>
-                        <a:t>27</a:t>
+                        <a:t>25</a:t>
                       </a:r>
                     </a:p>
                   </a:txBody>
@@ -7306,7 +7306,7 @@
                         </a:defRPr>
                       </a:pPr>
                       <a:r>
-                        <a:t>-10</a:t>
+                        <a:t>-12</a:t>
                       </a:r>
                     </a:p>
                   </a:txBody>
@@ -7329,7 +7329,7 @@
                         </a:defRPr>
                       </a:pPr>
                       <a:r>
-                        <a:t>✅ Improved (-27%)</a:t>
+                        <a:t>✅ Improved (-32%)</a:t>
                       </a:r>
                     </a:p>
                   </a:txBody>
@@ -7423,7 +7423,7 @@
                         </a:defRPr>
                       </a:pPr>
                       <a:r>
-                        <a:t>32</a:t>
+                        <a:t>36</a:t>
                       </a:r>
                     </a:p>
                   </a:txBody>
@@ -7446,7 +7446,7 @@
                         </a:defRPr>
                       </a:pPr>
                       <a:r>
-                        <a:t>+9</a:t>
+                        <a:t>+13</a:t>
                       </a:r>
                     </a:p>
                   </a:txBody>
@@ -7469,7 +7469,7 @@
                         </a:defRPr>
                       </a:pPr>
                       <a:r>
-                        <a:t>❌ Worse (+39%)</a:t>
+                        <a:t>❌ Worse (+57%)</a:t>
                       </a:r>
                     </a:p>
                   </a:txBody>
@@ -7563,7 +7563,7 @@
                         </a:defRPr>
                       </a:pPr>
                       <a:r>
-                        <a:t>5</a:t>
+                        <a:t>6</a:t>
                       </a:r>
                     </a:p>
                   </a:txBody>
@@ -7586,7 +7586,7 @@
                         </a:defRPr>
                       </a:pPr>
                       <a:r>
-                        <a:t>+1</a:t>
+                        <a:t>+2</a:t>
                       </a:r>
                     </a:p>
                   </a:txBody>
@@ -7609,7 +7609,7 @@
                         </a:defRPr>
                       </a:pPr>
                       <a:r>
-                        <a:t>➡️ Flat</a:t>
+                        <a:t>❌ Worse</a:t>
                       </a:r>
                     </a:p>
                   </a:txBody>
@@ -7703,7 +7703,7 @@
                         </a:defRPr>
                       </a:pPr>
                       <a:r>
-                        <a:t>95</a:t>
+                        <a:t>152</a:t>
                       </a:r>
                     </a:p>
                   </a:txBody>
@@ -7726,7 +7726,7 @@
                         </a:defRPr>
                       </a:pPr>
                       <a:r>
-                        <a:t>+45</a:t>
+                        <a:t>+102</a:t>
                       </a:r>
                     </a:p>
                   </a:txBody>
@@ -7749,7 +7749,7 @@
                         </a:defRPr>
                       </a:pPr>
                       <a:r>
-                        <a:t>❌ Worse (+90%)</a:t>
+                        <a:t>❌ Worse (+204%)</a:t>
                       </a:r>
                     </a:p>
                   </a:txBody>
@@ -7843,7 +7843,7 @@
                         </a:defRPr>
                       </a:pPr>
                       <a:r>
-                        <a:t>40</a:t>
+                        <a:t>60</a:t>
                       </a:r>
                     </a:p>
                   </a:txBody>
@@ -7866,7 +7866,7 @@
                         </a:defRPr>
                       </a:pPr>
                       <a:r>
-                        <a:t>+23</a:t>
+                        <a:t>+43</a:t>
                       </a:r>
                     </a:p>
                   </a:txBody>
@@ -7889,7 +7889,7 @@
                         </a:defRPr>
                       </a:pPr>
                       <a:r>
-                        <a:t>❌ Worse (+135%)</a:t>
+                        <a:t>❌ Worse (+253%)</a:t>
                       </a:r>
                     </a:p>
                   </a:txBody>
@@ -7983,7 +7983,7 @@
                         </a:defRPr>
                       </a:pPr>
                       <a:r>
-                        <a:t>12.6%</a:t>
+                        <a:t>TBD</a:t>
                       </a:r>
                     </a:p>
                   </a:txBody>
@@ -8006,7 +8006,7 @@
                         </a:defRPr>
                       </a:pPr>
                       <a:r>
-                        <a:t>-19pp</a:t>
+                        <a:t>—</a:t>
                       </a:r>
                     </a:p>
                   </a:txBody>
@@ -8204,7 +8204,7 @@
               </a:defRPr>
             </a:pPr>
             <a:r>
-              <a:t>Dana Mittelman — Priority: REGRESSION (54 bugs)</a:t>
+              <a:t>Dana Mittelman — Priority: REGRESSION (95 bugs)</a:t>
             </a:r>
           </a:p>
         </p:txBody>
@@ -8329,7 +8329,7 @@
               </a:defRPr>
             </a:pPr>
             <a:r>
-              <a:t>    Target: Nils regressions &lt; 20 (down from 47)</a:t>
+              <a:t>    Target: Nils regressions &lt; 20 (down from 60)</a:t>
             </a:r>
           </a:p>
           <a:p>
@@ -8557,7 +8557,7 @@
               </a:defRPr>
             </a:pPr>
             <a:r>
-              <a:t>    Target: Driver regressions &lt; 4 (down from 8)</a:t>
+              <a:t>    Target: Driver regressions &lt; 4 (down from 11)</a:t>
             </a:r>
           </a:p>
           <a:p>
@@ -9535,7 +9535,7 @@
               </a:defRPr>
             </a:pPr>
             <a:r>
-              <a:t>  • Nils (47): Squad - Eng - Nils + affectedVersion=10.9 + Regression=Yes</a:t>
+              <a:t>  • Nils (60): Squad - Eng - Nils + affectedVersion=10.9 + Regression=Yes</a:t>
             </a:r>
           </a:p>
           <a:p>
@@ -9550,7 +9550,7 @@
               </a:defRPr>
             </a:pPr>
             <a:r>
-              <a:t>  • GreenBoat (17): Squad GreenBoat + affectedVersion=10.9 + Regression=Yes</a:t>
+              <a:t>  • GreenBoat (22): Squad GreenBoat + affectedVersion=10.9 + Regression=Yes</a:t>
             </a:r>
           </a:p>
           <a:p>
@@ -9565,7 +9565,7 @@
               </a:defRPr>
             </a:pPr>
             <a:r>
-              <a:t>  • Driver (8): Squad Driver + affectedVersion=10.9 + Regression=Yes</a:t>
+              <a:t>  • Cloud Compliance (19): Squad Cloud Compliance + affectedVersion=10.9 + Regression=Yes</a:t>
             </a:r>
           </a:p>
           <a:p>
@@ -9580,7 +9580,7 @@
               </a:defRPr>
             </a:pPr>
             <a:r>
-              <a:t>  • Azure (6): Squad Cloud Azure + affectedVersion=10.9 + Regression=Yes</a:t>
+              <a:t>  • Driver (11): Squad Driver + affectedVersion=10.9 + Regression=Yes</a:t>
             </a:r>
           </a:p>
           <a:p>
@@ -9595,7 +9595,7 @@
               </a:defRPr>
             </a:pPr>
             <a:r>
-              <a:t>  • VRA (5): Squad VRA + affectedVersion=10.9 + Regression=Yes</a:t>
+              <a:t>  • VRA (10): Squad VRA + affectedVersion=10.9 + Regression=Yes</a:t>
             </a:r>
           </a:p>
           <a:p>
@@ -9610,7 +9610,22 @@
               </a:defRPr>
             </a:pPr>
             <a:r>
-              <a:t>  • Apex (3): Squad Apex Legends + affectedVersion=10.9 + Regression=Yes</a:t>
+              <a:t>  • Azure (8): Squad Cloud Azure + affectedVersion=10.9 + Regression=Yes</a:t>
+            </a:r>
+          </a:p>
+          <a:p>
+            <a:pPr>
+              <a:spcAft>
+                <a:spcPts val="600"/>
+              </a:spcAft>
+              <a:defRPr sz="1300" b="0">
+                <a:solidFill>
+                  <a:srgbClr val="BDBDBD"/>
+                </a:solidFill>
+              </a:defRPr>
+            </a:pPr>
+            <a:r>
+              <a:t>  • Apex (8): Squad Apex Legends + affectedVersion=10.9 + Regression=Yes</a:t>
             </a:r>
           </a:p>
           <a:p>
@@ -9766,7 +9781,7 @@
               </a:defRPr>
             </a:pPr>
             <a:r>
-              <a:t>  FF discipline improved (-27%), Dana CF→zero, Rajeev FF halved</a:t>
+              <a:t>  FF improved (-32%), Dana CF 6→2, Rajeev FF 30→11</a:t>
             </a:r>
           </a:p>
           <a:p>
@@ -9808,7 +9823,7 @@
               </a:defRPr>
             </a:pPr>
             <a:r>
-              <a:t>  Regressions +90%, CF +39%, Automation rate halved</a:t>
+              <a:t>  Regressions +204% (50→152), CF +57%, Automation rate dropped</a:t>
             </a:r>
           </a:p>
           <a:p>
@@ -9865,7 +9880,7 @@
               </a:defRPr>
             </a:pPr>
             <a:r>
-              <a:t>  React/Nils tweaks, QA queue bottleneck (Rajeev), late requirements</a:t>
+              <a:t>  React/Nils (60), Cloud Compliance (19), QA queue (Rajeev), late requirements</a:t>
             </a:r>
           </a:p>
           <a:p>
@@ -10173,7 +10188,7 @@
                         </a:defRPr>
                       </a:pPr>
                       <a:r>
-                        <a:t>7→4 ✅</a:t>
+                        <a:t>7→6 ✅</a:t>
                       </a:r>
                     </a:p>
                   </a:txBody>
@@ -10196,7 +10211,7 @@
                         </a:defRPr>
                       </a:pPr>
                       <a:r>
-                        <a:t>0→10 ❌</a:t>
+                        <a:t>0→8 ❌</a:t>
                       </a:r>
                     </a:p>
                   </a:txBody>
@@ -10219,7 +10234,7 @@
                         </a:defRPr>
                       </a:pPr>
                       <a:r>
-                        <a:t>30→13 ✅</a:t>
+                        <a:t>30→11 ✅</a:t>
                       </a:r>
                     </a:p>
                   </a:txBody>
@@ -10267,7 +10282,7 @@
                         </a:defRPr>
                       </a:pPr>
                       <a:r>
-                        <a:t>6→0 ✅</a:t>
+                        <a:t>6→2 ✅</a:t>
                       </a:r>
                     </a:p>
                   </a:txBody>
@@ -10290,7 +10305,7 @@
                         </a:defRPr>
                       </a:pPr>
                       <a:r>
-                        <a:t>3→6 ❌</a:t>
+                        <a:t>3→9 ❌</a:t>
                       </a:r>
                     </a:p>
                   </a:txBody>
@@ -10313,7 +10328,7 @@
                         </a:defRPr>
                       </a:pPr>
                       <a:r>
-                        <a:t>14→26 ❌</a:t>
+                        <a:t>14→25 ❌</a:t>
                       </a:r>
                     </a:p>
                   </a:txBody>
@@ -10361,7 +10376,7 @@
                         </a:defRPr>
                       </a:pPr>
                       <a:r>
-                        <a:t>2→1 ✅</a:t>
+                        <a:t>2→2 ➡️</a:t>
                       </a:r>
                     </a:p>
                   </a:txBody>
@@ -10455,7 +10470,7 @@
                         </a:defRPr>
                       </a:pPr>
                       <a:r>
-                        <a:t>19→54 ❌</a:t>
+                        <a:t>19→95 ❌</a:t>
                       </a:r>
                     </a:p>
                   </a:txBody>
@@ -10478,7 +10493,7 @@
                         </a:defRPr>
                       </a:pPr>
                       <a:r>
-                        <a:t>4→14 ❌</a:t>
+                        <a:t>4→27 ❌</a:t>
                       </a:r>
                     </a:p>
                   </a:txBody>
@@ -10501,7 +10516,7 @@
                         </a:defRPr>
                       </a:pPr>
                       <a:r>
-                        <a:t>27→27 ➡️</a:t>
+                        <a:t>27→30 ❌</a:t>
                       </a:r>
                     </a:p>
                   </a:txBody>
@@ -10549,7 +10564,7 @@
                         </a:defRPr>
                       </a:pPr>
                       <a:r>
-                        <a:t>11→24 ❌</a:t>
+                        <a:t>11→37 ❌</a:t>
                       </a:r>
                     </a:p>
                   </a:txBody>
@@ -10572,7 +10587,7 @@
                         </a:defRPr>
                       </a:pPr>
                       <a:r>
-                        <a:t>1→10 ❌</a:t>
+                        <a:t>1→17 ❌</a:t>
                       </a:r>
                     </a:p>
                   </a:txBody>
@@ -10643,12 +10658,12 @@
                         </a:defRPr>
                       </a:pPr>
                       <a:r>
-                        <a:t>FF/CF great</a:t>
-                      </a:r>
-                    </a:p>
-                    <a:p>
-                      <a:r>
-                        <a:t>Regressions bad</a:t>
+                        <a:t>FF/CF improved</a:t>
+                      </a:r>
+                    </a:p>
+                    <a:p>
+                      <a:r>
+                        <a:t>Regressions 5×</a:t>
                       </a:r>
                     </a:p>
                   </a:txBody>
@@ -10808,7 +10823,7 @@
               </a:defRPr>
             </a:pPr>
             <a:r>
-              <a:t>FF discipline improved: 37 → 27 breaches (-27%)</a:t>
+              <a:t>FF discipline improved: 37 → 25 breaches (-32%)</a:t>
             </a:r>
           </a:p>
           <a:p>
@@ -10823,7 +10838,7 @@
               </a:defRPr>
             </a:pPr>
             <a:r>
-              <a:t>Dana CF breach → zero stories at Code Freeze</a:t>
+              <a:t>Dana CF breach: 6 → 2 stories at Code Freeze</a:t>
             </a:r>
           </a:p>
           <a:p>
@@ -10838,7 +10853,7 @@
               </a:defRPr>
             </a:pPr>
             <a:r>
-              <a:t>Rajeev FF halved: 30 → 13</a:t>
+              <a:t>Rajeev FF significantly improved: 30 → 11</a:t>
             </a:r>
           </a:p>
           <a:p>
@@ -10853,7 +10868,7 @@
               </a:defRPr>
             </a:pPr>
             <a:r>
-              <a:t>Apex regressions halved: 6 → 3</a:t>
+              <a:t>Dana FF improved: 7 → 6</a:t>
             </a:r>
           </a:p>
           <a:p>
@@ -10868,7 +10883,7 @@
               </a:defRPr>
             </a:pPr>
             <a:r>
-              <a:t>Rajeev regressions stable despite more scope</a:t>
+              <a:t>Rajeev regressions nearly stable: 27 → 30</a:t>
             </a:r>
           </a:p>
           <a:p>
@@ -11060,7 +11075,7 @@
               </a:defRPr>
             </a:pPr>
             <a:r>
-              <a:t>Regression Total: 50 → 95 (+90%) — Top Contributors</a:t>
+              <a:t>Regression Total: 50 → 152 (+204%) — Top Contributors</a:t>
             </a:r>
           </a:p>
         </p:txBody>
@@ -11075,7 +11090,7 @@
         </p:nvGraphicFramePr>
         <p:xfrm>
           <a:off x="365760" y="1005840"/>
-          <a:ext cx="11338560" cy="2560320"/>
+          <a:ext cx="11338560" cy="2926080"/>
         </p:xfrm>
         <a:graphic>
           <a:graphicData uri="http://schemas.openxmlformats.org/drawingml/2006/table">
@@ -11267,7 +11282,7 @@
                         </a:defRPr>
                       </a:pPr>
                       <a:r>
-                        <a:t>47</a:t>
+                        <a:t>60</a:t>
                       </a:r>
                     </a:p>
                   </a:txBody>
@@ -11290,7 +11305,7 @@
                         </a:defRPr>
                       </a:pPr>
                       <a:r>
-                        <a:t>+31</a:t>
+                        <a:t>+44</a:t>
                       </a:r>
                     </a:p>
                   </a:txBody>
@@ -11384,7 +11399,7 @@
                         </a:defRPr>
                       </a:pPr>
                       <a:r>
-                        <a:t>17</a:t>
+                        <a:t>22</a:t>
                       </a:r>
                     </a:p>
                   </a:txBody>
@@ -11407,7 +11422,7 @@
                         </a:defRPr>
                       </a:pPr>
                       <a:r>
-                        <a:t>+2</a:t>
+                        <a:t>+7</a:t>
                       </a:r>
                     </a:p>
                   </a:txBody>
@@ -11455,7 +11470,7 @@
                         </a:defRPr>
                       </a:pPr>
                       <a:r>
-                        <a:t>Driver (Shlomi)</a:t>
+                        <a:t>Cloud Compliance (Dana)</a:t>
                       </a:r>
                     </a:p>
                   </a:txBody>
@@ -11478,7 +11493,7 @@
                         </a:defRPr>
                       </a:pPr>
                       <a:r>
-                        <a:t>1</a:t>
+                        <a:t>—</a:t>
                       </a:r>
                     </a:p>
                   </a:txBody>
@@ -11501,7 +11516,7 @@
                         </a:defRPr>
                       </a:pPr>
                       <a:r>
-                        <a:t>8</a:t>
+                        <a:t>19</a:t>
                       </a:r>
                     </a:p>
                   </a:txBody>
@@ -11524,7 +11539,7 @@
                         </a:defRPr>
                       </a:pPr>
                       <a:r>
-                        <a:t>+7</a:t>
+                        <a:t>—</a:t>
                       </a:r>
                     </a:p>
                   </a:txBody>
@@ -11547,7 +11562,7 @@
                         </a:defRPr>
                       </a:pPr>
                       <a:r>
-                        <a:t>VME/VAIO — low quality dev testing</a:t>
+                        <a:t>Security/compliance bugs, 0 by automation</a:t>
                       </a:r>
                     </a:p>
                   </a:txBody>
@@ -11572,7 +11587,7 @@
                         </a:defRPr>
                       </a:pPr>
                       <a:r>
-                        <a:t>Azure (Dana)</a:t>
+                        <a:t>Driver (Shlomi)</a:t>
                       </a:r>
                     </a:p>
                   </a:txBody>
@@ -11595,7 +11610,7 @@
                         </a:defRPr>
                       </a:pPr>
                       <a:r>
-                        <a:t>3</a:t>
+                        <a:t>1</a:t>
                       </a:r>
                     </a:p>
                   </a:txBody>
@@ -11618,7 +11633,7 @@
                         </a:defRPr>
                       </a:pPr>
                       <a:r>
-                        <a:t>6</a:t>
+                        <a:t>11</a:t>
                       </a:r>
                     </a:p>
                   </a:txBody>
@@ -11641,7 +11656,7 @@
                         </a:defRPr>
                       </a:pPr>
                       <a:r>
-                        <a:t>+3</a:t>
+                        <a:t>+10</a:t>
                       </a:r>
                     </a:p>
                   </a:txBody>
@@ -11664,7 +11679,7 @@
                         </a:defRPr>
                       </a:pPr>
                       <a:r>
-                        <a:t>GPv2 performance, recovery stuck</a:t>
+                        <a:t>VME/VAIO — low quality dev testing</a:t>
                       </a:r>
                     </a:p>
                   </a:txBody>
@@ -11735,7 +11750,7 @@
                         </a:defRPr>
                       </a:pPr>
                       <a:r>
-                        <a:t>5</a:t>
+                        <a:t>10</a:t>
                       </a:r>
                     </a:p>
                   </a:txBody>
@@ -11758,7 +11773,7 @@
                         </a:defRPr>
                       </a:pPr>
                       <a:r>
-                        <a:t>+2</a:t>
+                        <a:t>+7</a:t>
                       </a:r>
                     </a:p>
                   </a:txBody>
@@ -11806,13 +11821,130 @@
                         </a:defRPr>
                       </a:pPr>
                       <a:r>
+                        <a:t>Azure (Dana)</a:t>
+                      </a:r>
+                    </a:p>
+                  </a:txBody>
+                  <a:tcPr>
+                    <a:solidFill>
+                      <a:srgbClr val="1B1B2F"/>
+                    </a:solidFill>
+                  </a:tcPr>
+                </a:tc>
+                <a:tc>
+                  <a:txBody>
+                    <a:bodyPr/>
+                    <a:lstStyle/>
+                    <a:p>
+                      <a:pPr>
+                        <a:defRPr sz="1200">
+                          <a:solidFill>
+                            <a:srgbClr val="FFFFFF"/>
+                          </a:solidFill>
+                        </a:defRPr>
+                      </a:pPr>
+                      <a:r>
+                        <a:t>3</a:t>
+                      </a:r>
+                    </a:p>
+                  </a:txBody>
+                  <a:tcPr>
+                    <a:solidFill>
+                      <a:srgbClr val="1B1B2F"/>
+                    </a:solidFill>
+                  </a:tcPr>
+                </a:tc>
+                <a:tc>
+                  <a:txBody>
+                    <a:bodyPr/>
+                    <a:lstStyle/>
+                    <a:p>
+                      <a:pPr>
+                        <a:defRPr sz="1200">
+                          <a:solidFill>
+                            <a:srgbClr val="FFFFFF"/>
+                          </a:solidFill>
+                        </a:defRPr>
+                      </a:pPr>
+                      <a:r>
+                        <a:t>8</a:t>
+                      </a:r>
+                    </a:p>
+                  </a:txBody>
+                  <a:tcPr>
+                    <a:solidFill>
+                      <a:srgbClr val="1B1B2F"/>
+                    </a:solidFill>
+                  </a:tcPr>
+                </a:tc>
+                <a:tc>
+                  <a:txBody>
+                    <a:bodyPr/>
+                    <a:lstStyle/>
+                    <a:p>
+                      <a:pPr>
+                        <a:defRPr sz="1200">
+                          <a:solidFill>
+                            <a:srgbClr val="FFFFFF"/>
+                          </a:solidFill>
+                        </a:defRPr>
+                      </a:pPr>
+                      <a:r>
+                        <a:t>+5</a:t>
+                      </a:r>
+                    </a:p>
+                  </a:txBody>
+                  <a:tcPr>
+                    <a:solidFill>
+                      <a:srgbClr val="1B1B2F"/>
+                    </a:solidFill>
+                  </a:tcPr>
+                </a:tc>
+                <a:tc>
+                  <a:txBody>
+                    <a:bodyPr/>
+                    <a:lstStyle/>
+                    <a:p>
+                      <a:pPr>
+                        <a:defRPr sz="1200">
+                          <a:solidFill>
+                            <a:srgbClr val="FFFFFF"/>
+                          </a:solidFill>
+                        </a:defRPr>
+                      </a:pPr>
+                      <a:r>
+                        <a:t>GPv2 performance, recovery stuck</a:t>
+                      </a:r>
+                    </a:p>
+                  </a:txBody>
+                  <a:tcPr>
+                    <a:solidFill>
+                      <a:srgbClr val="1B1B2F"/>
+                    </a:solidFill>
+                  </a:tcPr>
+                </a:tc>
+              </a:tr>
+              <a:tr h="365760">
+                <a:tc>
+                  <a:txBody>
+                    <a:bodyPr/>
+                    <a:lstStyle/>
+                    <a:p>
+                      <a:pPr>
+                        <a:defRPr sz="1200">
+                          <a:solidFill>
+                            <a:srgbClr val="FFFFFF"/>
+                          </a:solidFill>
+                        </a:defRPr>
+                      </a:pPr>
+                      <a:r>
                         <a:t>Apex (Rajeev)</a:t>
                       </a:r>
                     </a:p>
                   </a:txBody>
                   <a:tcPr>
                     <a:solidFill>
-                      <a:srgbClr val="1B1B2F"/>
+                      <a:srgbClr val="22223A"/>
                     </a:solidFill>
                   </a:tcPr>
                 </a:tc>
@@ -11835,76 +11967,76 @@
                   </a:txBody>
                   <a:tcPr>
                     <a:solidFill>
-                      <a:srgbClr val="1B1B2F"/>
-                    </a:solidFill>
-                  </a:tcPr>
-                </a:tc>
-                <a:tc>
-                  <a:txBody>
-                    <a:bodyPr/>
-                    <a:lstStyle/>
-                    <a:p>
-                      <a:pPr>
-                        <a:defRPr sz="1200">
-                          <a:solidFill>
-                            <a:srgbClr val="FFFFFF"/>
-                          </a:solidFill>
-                        </a:defRPr>
-                      </a:pPr>
-                      <a:r>
-                        <a:t>3</a:t>
-                      </a:r>
-                    </a:p>
-                  </a:txBody>
-                  <a:tcPr>
-                    <a:solidFill>
-                      <a:srgbClr val="1B1B2F"/>
-                    </a:solidFill>
-                  </a:tcPr>
-                </a:tc>
-                <a:tc>
-                  <a:txBody>
-                    <a:bodyPr/>
-                    <a:lstStyle/>
-                    <a:p>
-                      <a:pPr>
-                        <a:defRPr sz="1200">
-                          <a:solidFill>
-                            <a:srgbClr val="FFFFFF"/>
-                          </a:solidFill>
-                        </a:defRPr>
-                      </a:pPr>
-                      <a:r>
-                        <a:t>-3</a:t>
-                      </a:r>
-                    </a:p>
-                  </a:txBody>
-                  <a:tcPr>
-                    <a:solidFill>
-                      <a:srgbClr val="1B1B2F"/>
-                    </a:solidFill>
-                  </a:tcPr>
-                </a:tc>
-                <a:tc>
-                  <a:txBody>
-                    <a:bodyPr/>
-                    <a:lstStyle/>
-                    <a:p>
-                      <a:pPr>
-                        <a:defRPr sz="1200">
-                          <a:solidFill>
-                            <a:srgbClr val="FFFFFF"/>
-                          </a:solidFill>
-                        </a:defRPr>
-                      </a:pPr>
-                      <a:r>
-                        <a:t>✅ Improved</a:t>
-                      </a:r>
-                    </a:p>
-                  </a:txBody>
-                  <a:tcPr>
-                    <a:solidFill>
-                      <a:srgbClr val="1B1B2F"/>
+                      <a:srgbClr val="22223A"/>
+                    </a:solidFill>
+                  </a:tcPr>
+                </a:tc>
+                <a:tc>
+                  <a:txBody>
+                    <a:bodyPr/>
+                    <a:lstStyle/>
+                    <a:p>
+                      <a:pPr>
+                        <a:defRPr sz="1200">
+                          <a:solidFill>
+                            <a:srgbClr val="FFFFFF"/>
+                          </a:solidFill>
+                        </a:defRPr>
+                      </a:pPr>
+                      <a:r>
+                        <a:t>8</a:t>
+                      </a:r>
+                    </a:p>
+                  </a:txBody>
+                  <a:tcPr>
+                    <a:solidFill>
+                      <a:srgbClr val="22223A"/>
+                    </a:solidFill>
+                  </a:tcPr>
+                </a:tc>
+                <a:tc>
+                  <a:txBody>
+                    <a:bodyPr/>
+                    <a:lstStyle/>
+                    <a:p>
+                      <a:pPr>
+                        <a:defRPr sz="1200">
+                          <a:solidFill>
+                            <a:srgbClr val="FFFFFF"/>
+                          </a:solidFill>
+                        </a:defRPr>
+                      </a:pPr>
+                      <a:r>
+                        <a:t>+2</a:t>
+                      </a:r>
+                    </a:p>
+                  </a:txBody>
+                  <a:tcPr>
+                    <a:solidFill>
+                      <a:srgbClr val="22223A"/>
+                    </a:solidFill>
+                  </a:tcPr>
+                </a:tc>
+                <a:tc>
+                  <a:txBody>
+                    <a:bodyPr/>
+                    <a:lstStyle/>
+                    <a:p>
+                      <a:pPr>
+                        <a:defRPr sz="1200">
+                          <a:solidFill>
+                            <a:srgbClr val="FFFFFF"/>
+                          </a:solidFill>
+                        </a:defRPr>
+                      </a:pPr>
+                      <a:r>
+                        <a:t>Secret Centralization + late testing</a:t>
+                      </a:r>
+                    </a:p>
+                  </a:txBody>
+                  <a:tcPr>
+                    <a:solidFill>
+                      <a:srgbClr val="22223A"/>
                     </a:solidFill>
                   </a:tcPr>
                 </a:tc>
@@ -12007,7 +12139,7 @@
               </a:defRPr>
             </a:pPr>
             <a:r>
-              <a:t>FF Breaches (27 total):</a:t>
+              <a:t>FF Breaches (25 total):</a:t>
             </a:r>
           </a:p>
           <a:p>
@@ -12067,7 +12199,7 @@
               </a:defRPr>
             </a:pPr>
             <a:r>
-              <a:t>  • Nils (2): FE tweaks enabled late (same as 10.8!)</a:t>
+              <a:t>  • Nils (2), Azure (2), AI Agents (2), Driver (1)</a:t>
             </a:r>
           </a:p>
           <a:p>
@@ -12094,7 +12226,7 @@
               </a:defRPr>
             </a:pPr>
             <a:r>
-              <a:t>CF Breaches (32 stories):</a:t>
+              <a:t>CF Breaches (36 stories):</a:t>
             </a:r>
           </a:p>
           <a:p>
@@ -12139,7 +12271,7 @@
               </a:defRPr>
             </a:pPr>
             <a:r>
-              <a:t>  • Cyber Resilience (4): LTS late start</a:t>
+              <a:t>  • Mavka (4), Cyber Resilience (4): Late start</a:t>
             </a:r>
           </a:p>
           <a:p>
@@ -12154,7 +12286,7 @@
               </a:defRPr>
             </a:pPr>
             <a:r>
-              <a:t>  • Driver (2): Urgent HF + HV stabilization</a:t>
+              <a:t>  • AI Agents (2), Driver (1)</a:t>
             </a:r>
           </a:p>
         </p:txBody>
@@ -12215,7 +12347,7 @@
               </a:defRPr>
             </a:pPr>
             <a:r>
-              <a:t>Automation Detection: 32% → 12.6%</a:t>
+              <a:t>Automation Detection Rate — Dropped</a:t>
             </a:r>
           </a:p>
         </p:txBody>
@@ -12295,7 +12427,7 @@
               </a:defRPr>
             </a:pPr>
             <a:r>
-              <a:t>  • New bugs concentrated in React (Nils) and VME (Driver)</a:t>
+              <a:t>  • New bugs concentrated in React (Nils=60) and VME (Driver=11)</a:t>
             </a:r>
           </a:p>
           <a:p>
@@ -12348,6 +12480,21 @@
               <a:spcAft>
                 <a:spcPts val="600"/>
               </a:spcAft>
+              <a:defRPr sz="1600" b="0">
+                <a:solidFill>
+                  <a:srgbClr val="FFFFFF"/>
+                </a:solidFill>
+              </a:defRPr>
+            </a:pPr>
+            <a:r>
+              <a:t>  • Cloud Compliance (19 regressions): 0/19 found by automation</a:t>
+            </a:r>
+          </a:p>
+          <a:p>
+            <a:pPr>
+              <a:spcAft>
+                <a:spcPts val="600"/>
+              </a:spcAft>
               <a:defRPr sz="1000" b="0">
                 <a:solidFill>
                   <a:srgbClr val="FFFFFF"/>
@@ -12367,7 +12514,7 @@
               </a:defRPr>
             </a:pPr>
             <a:r>
-              <a:t>Impact: 12 of 95 bugs found by automation (vs 16/50 in 10.8)</a:t>
+              <a:t>152 regressions total — vast majority in low-automation areas</a:t>
             </a:r>
           </a:p>
         </p:txBody>

</xml_diff>

<commit_message>
Add clickable Jira hyperlinks to PPTX slide 25
</commit_message>
<xml_diff>
--- a/retro_109_presentation.pptx
+++ b/retro_109_presentation.pptx
@@ -9373,8 +9373,8 @@
         </p:nvSpPr>
         <p:spPr>
           <a:xfrm>
-            <a:off x="457200" y="274320"/>
-            <a:ext cx="10972800" cy="731520"/>
+            <a:off x="457200" y="182880"/>
+            <a:ext cx="10972800" cy="640080"/>
           </a:xfrm>
           <a:prstGeom prst="rect">
             <a:avLst/>
@@ -9388,14 +9388,14 @@
           <a:lstStyle/>
           <a:p>
             <a:pPr>
-              <a:defRPr sz="2800" b="1">
+              <a:defRPr sz="2600" b="1">
                 <a:solidFill>
                   <a:srgbClr val="4EC5F1"/>
                 </a:solidFill>
               </a:defRPr>
             </a:pPr>
             <a:r>
-              <a:t>Jira Links — Drill Down &amp; Analyze</a:t>
+              <a:t>Jira Links — Click to Verify</a:t>
             </a:r>
           </a:p>
         </p:txBody>
@@ -9408,8 +9408,8 @@
         </p:nvSpPr>
         <p:spPr>
           <a:xfrm>
-            <a:off x="457200" y="1097280"/>
-            <a:ext cx="11247120" cy="5303520"/>
+            <a:off x="457200" y="914400"/>
+            <a:ext cx="11247120" cy="5486400"/>
           </a:xfrm>
           <a:prstGeom prst="rect">
             <a:avLst/>
@@ -9424,250 +9424,278 @@
           <a:p>
             <a:pPr>
               <a:spcAft>
-                <a:spcPts val="600"/>
-              </a:spcAft>
-              <a:defRPr sz="1800" b="1">
+                <a:spcPts val="300"/>
+              </a:spcAft>
+            </a:pPr>
+            <a:r>
+              <a:rPr sz="1600" b="1">
                 <a:solidFill>
                   <a:srgbClr val="4EC5F1"/>
                 </a:solidFill>
-              </a:defRPr>
-            </a:pPr>
-            <a:r>
-              <a:t>Dashboard &amp; Filters:</a:t>
-            </a:r>
-          </a:p>
-          <a:p>
-            <a:pPr>
-              <a:spcAft>
-                <a:spcPts val="600"/>
-              </a:spcAft>
-              <a:defRPr sz="1300" b="0">
-                <a:solidFill>
-                  <a:srgbClr val="BDBDBD"/>
-                </a:solidFill>
-              </a:defRPr>
-            </a:pPr>
-            <a:r>
-              <a:t>  • Dashboard: https://zerto.atlassian.net/jira/dashboards/10405</a:t>
-            </a:r>
-          </a:p>
-          <a:p>
-            <a:pPr>
-              <a:spcAft>
-                <a:spcPts val="600"/>
-              </a:spcAft>
-              <a:defRPr sz="1300" b="0">
-                <a:solidFill>
-                  <a:srgbClr val="BDBDBD"/>
-                </a:solidFill>
-              </a:defRPr>
-            </a:pPr>
-            <a:r>
-              <a:t>  • FF Breach: https://zerto.atlassian.net/issues/?filter=21636</a:t>
-            </a:r>
-          </a:p>
-          <a:p>
-            <a:pPr>
-              <a:spcAft>
-                <a:spcPts val="600"/>
-              </a:spcAft>
-              <a:defRPr sz="1300" b="0">
-                <a:solidFill>
-                  <a:srgbClr val="BDBDBD"/>
-                </a:solidFill>
-              </a:defRPr>
-            </a:pPr>
-            <a:r>
-              <a:t>  • CF Stories: https://zerto.atlassian.net/issues/?filter=21637</a:t>
-            </a:r>
-          </a:p>
-          <a:p>
-            <a:pPr>
-              <a:spcAft>
-                <a:spcPts val="600"/>
-              </a:spcAft>
-              <a:defRPr sz="1300" b="0">
-                <a:solidFill>
-                  <a:srgbClr val="BDBDBD"/>
-                </a:solidFill>
-              </a:defRPr>
-            </a:pPr>
-            <a:r>
-              <a:t>  • CF Bugs: https://zerto.atlassian.net/issues/?filter=21638</a:t>
-            </a:r>
-          </a:p>
-          <a:p>
-            <a:pPr>
-              <a:spcAft>
-                <a:spcPts val="600"/>
-              </a:spcAft>
-              <a:defRPr sz="600" b="0">
-                <a:solidFill>
-                  <a:srgbClr val="FFFFFF"/>
-                </a:solidFill>
-              </a:defRPr>
-            </a:pPr>
-          </a:p>
-          <a:p>
-            <a:pPr>
-              <a:spcAft>
-                <a:spcPts val="600"/>
-              </a:spcAft>
-              <a:defRPr sz="1800" b="1">
+              </a:rPr>
+              <a:t>Filters:</a:t>
+            </a:r>
+          </a:p>
+          <a:p>
+            <a:pPr>
+              <a:spcAft>
+                <a:spcPts val="300"/>
+              </a:spcAft>
+            </a:pPr>
+            <a:r>
+              <a:rPr sz="1300">
+                <a:solidFill>
+                  <a:srgbClr val="58A6FF"/>
+                </a:solidFill>
+                <a:hlinkClick r:id="rId2"/>
+              </a:rPr>
+              <a:t>  10.9 Dashboard</a:t>
+            </a:r>
+          </a:p>
+          <a:p>
+            <a:pPr>
+              <a:spcAft>
+                <a:spcPts val="300"/>
+              </a:spcAft>
+            </a:pPr>
+            <a:r>
+              <a:rPr sz="1300">
+                <a:solidFill>
+                  <a:srgbClr val="58A6FF"/>
+                </a:solidFill>
+                <a:hlinkClick r:id="rId3"/>
+              </a:rPr>
+              <a:t>  FF Breach (25 stories)</a:t>
+            </a:r>
+          </a:p>
+          <a:p>
+            <a:pPr>
+              <a:spcAft>
+                <a:spcPts val="300"/>
+              </a:spcAft>
+            </a:pPr>
+            <a:r>
+              <a:rPr sz="1300">
+                <a:solidFill>
+                  <a:srgbClr val="58A6FF"/>
+                </a:solidFill>
+                <a:hlinkClick r:id="rId4"/>
+              </a:rPr>
+              <a:t>  CF Breach Stories (36)</a:t>
+            </a:r>
+          </a:p>
+          <a:p>
+            <a:pPr>
+              <a:spcAft>
+                <a:spcPts val="300"/>
+              </a:spcAft>
+            </a:pPr>
+            <a:r>
+              <a:rPr sz="1300">
+                <a:solidFill>
+                  <a:srgbClr val="58A6FF"/>
+                </a:solidFill>
+                <a:hlinkClick r:id="rId5"/>
+              </a:rPr>
+              <a:t>  CF Breach Bugs (6)</a:t>
+            </a:r>
+          </a:p>
+          <a:p>
+            <a:pPr>
+              <a:spcAft>
+                <a:spcPts val="400"/>
+              </a:spcAft>
+            </a:pPr>
+          </a:p>
+          <a:p>
+            <a:pPr>
+              <a:spcAft>
+                <a:spcPts val="300"/>
+              </a:spcAft>
+            </a:pPr>
+            <a:r>
+              <a:rPr sz="1600" b="1">
                 <a:solidFill>
                   <a:srgbClr val="4EC5F1"/>
                 </a:solidFill>
-              </a:defRPr>
-            </a:pPr>
-            <a:r>
-              <a:t>Regressions per Squad (10.9):</a:t>
-            </a:r>
-          </a:p>
-          <a:p>
-            <a:pPr>
-              <a:spcAft>
-                <a:spcPts val="600"/>
-              </a:spcAft>
-              <a:defRPr sz="1300" b="0">
-                <a:solidFill>
-                  <a:srgbClr val="BDBDBD"/>
-                </a:solidFill>
-              </a:defRPr>
-            </a:pPr>
-            <a:r>
-              <a:t>  • Nils (60): Squad - Eng - Nils + affectedVersion=10.9 + Regression=Yes</a:t>
-            </a:r>
-          </a:p>
-          <a:p>
-            <a:pPr>
-              <a:spcAft>
-                <a:spcPts val="600"/>
-              </a:spcAft>
-              <a:defRPr sz="1300" b="0">
-                <a:solidFill>
-                  <a:srgbClr val="BDBDBD"/>
-                </a:solidFill>
-              </a:defRPr>
-            </a:pPr>
-            <a:r>
-              <a:t>  • GreenBoat (22): Squad GreenBoat + affectedVersion=10.9 + Regression=Yes</a:t>
-            </a:r>
-          </a:p>
-          <a:p>
-            <a:pPr>
-              <a:spcAft>
-                <a:spcPts val="600"/>
-              </a:spcAft>
-              <a:defRPr sz="1300" b="0">
-                <a:solidFill>
-                  <a:srgbClr val="BDBDBD"/>
-                </a:solidFill>
-              </a:defRPr>
-            </a:pPr>
-            <a:r>
-              <a:t>  • Cloud Compliance (19): Squad Cloud Compliance + affectedVersion=10.9 + Regression=Yes</a:t>
-            </a:r>
-          </a:p>
-          <a:p>
-            <a:pPr>
-              <a:spcAft>
-                <a:spcPts val="600"/>
-              </a:spcAft>
-              <a:defRPr sz="1300" b="0">
-                <a:solidFill>
-                  <a:srgbClr val="BDBDBD"/>
-                </a:solidFill>
-              </a:defRPr>
-            </a:pPr>
-            <a:r>
-              <a:t>  • Driver (11): Squad Driver + affectedVersion=10.9 + Regression=Yes</a:t>
-            </a:r>
-          </a:p>
-          <a:p>
-            <a:pPr>
-              <a:spcAft>
-                <a:spcPts val="600"/>
-              </a:spcAft>
-              <a:defRPr sz="1300" b="0">
-                <a:solidFill>
-                  <a:srgbClr val="BDBDBD"/>
-                </a:solidFill>
-              </a:defRPr>
-            </a:pPr>
-            <a:r>
-              <a:t>  • VRA (10): Squad VRA + affectedVersion=10.9 + Regression=Yes</a:t>
-            </a:r>
-          </a:p>
-          <a:p>
-            <a:pPr>
-              <a:spcAft>
-                <a:spcPts val="600"/>
-              </a:spcAft>
-              <a:defRPr sz="1300" b="0">
-                <a:solidFill>
-                  <a:srgbClr val="BDBDBD"/>
-                </a:solidFill>
-              </a:defRPr>
-            </a:pPr>
-            <a:r>
-              <a:t>  • Azure (8): Squad Cloud Azure + affectedVersion=10.9 + Regression=Yes</a:t>
-            </a:r>
-          </a:p>
-          <a:p>
-            <a:pPr>
-              <a:spcAft>
-                <a:spcPts val="600"/>
-              </a:spcAft>
-              <a:defRPr sz="1300" b="0">
-                <a:solidFill>
-                  <a:srgbClr val="BDBDBD"/>
-                </a:solidFill>
-              </a:defRPr>
-            </a:pPr>
-            <a:r>
-              <a:t>  • Apex (8): Squad Apex Legends + affectedVersion=10.9 + Regression=Yes</a:t>
-            </a:r>
-          </a:p>
-          <a:p>
-            <a:pPr>
-              <a:spcAft>
-                <a:spcPts val="600"/>
-              </a:spcAft>
-              <a:defRPr sz="600" b="0">
-                <a:solidFill>
-                  <a:srgbClr val="FFFFFF"/>
-                </a:solidFill>
-              </a:defRPr>
-            </a:pPr>
-          </a:p>
-          <a:p>
-            <a:pPr>
-              <a:spcAft>
-                <a:spcPts val="600"/>
-              </a:spcAft>
-              <a:defRPr sz="1800" b="1">
-                <a:solidFill>
-                  <a:srgbClr val="4EC5F1"/>
-                </a:solidFill>
-              </a:defRPr>
-            </a:pPr>
-            <a:r>
-              <a:t>All 10.9 Regressions:</a:t>
-            </a:r>
-          </a:p>
-          <a:p>
-            <a:pPr>
-              <a:spcAft>
-                <a:spcPts val="600"/>
-              </a:spcAft>
-              <a:defRPr sz="1300" b="0">
-                <a:solidFill>
-                  <a:srgbClr val="BDBDBD"/>
-                </a:solidFill>
-              </a:defRPr>
-            </a:pPr>
-            <a:r>
-              <a:t>  • affectedVersion=10.9 AND Regression=Yes AND status not in (Obsolete)</a:t>
+              </a:rPr>
+              <a:t>Regressions per Squad:</a:t>
+            </a:r>
+          </a:p>
+          <a:p>
+            <a:pPr>
+              <a:spcAft>
+                <a:spcPts val="300"/>
+              </a:spcAft>
+            </a:pPr>
+            <a:r>
+              <a:rPr sz="1300">
+                <a:solidFill>
+                  <a:srgbClr val="58A6FF"/>
+                </a:solidFill>
+                <a:hlinkClick r:id="rId6"/>
+              </a:rPr>
+              <a:t>  Nils — 60 regressions</a:t>
+            </a:r>
+          </a:p>
+          <a:p>
+            <a:pPr>
+              <a:spcAft>
+                <a:spcPts val="300"/>
+              </a:spcAft>
+            </a:pPr>
+            <a:r>
+              <a:rPr sz="1300">
+                <a:solidFill>
+                  <a:srgbClr val="58A6FF"/>
+                </a:solidFill>
+                <a:hlinkClick r:id="rId7"/>
+              </a:rPr>
+              <a:t>  GreenBoat — 22 regressions</a:t>
+            </a:r>
+          </a:p>
+          <a:p>
+            <a:pPr>
+              <a:spcAft>
+                <a:spcPts val="300"/>
+              </a:spcAft>
+            </a:pPr>
+            <a:r>
+              <a:rPr sz="1300">
+                <a:solidFill>
+                  <a:srgbClr val="58A6FF"/>
+                </a:solidFill>
+                <a:hlinkClick r:id="rId8"/>
+              </a:rPr>
+              <a:t>  Cloud Compliance — 19 regressions</a:t>
+            </a:r>
+          </a:p>
+          <a:p>
+            <a:pPr>
+              <a:spcAft>
+                <a:spcPts val="300"/>
+              </a:spcAft>
+            </a:pPr>
+            <a:r>
+              <a:rPr sz="1300">
+                <a:solidFill>
+                  <a:srgbClr val="58A6FF"/>
+                </a:solidFill>
+                <a:hlinkClick r:id="rId9"/>
+              </a:rPr>
+              <a:t>  Driver — 11 regressions</a:t>
+            </a:r>
+          </a:p>
+          <a:p>
+            <a:pPr>
+              <a:spcAft>
+                <a:spcPts val="300"/>
+              </a:spcAft>
+            </a:pPr>
+            <a:r>
+              <a:rPr sz="1300">
+                <a:solidFill>
+                  <a:srgbClr val="58A6FF"/>
+                </a:solidFill>
+                <a:hlinkClick r:id="rId10"/>
+              </a:rPr>
+              <a:t>  VRA — 10 regressions</a:t>
+            </a:r>
+          </a:p>
+          <a:p>
+            <a:pPr>
+              <a:spcAft>
+                <a:spcPts val="300"/>
+              </a:spcAft>
+            </a:pPr>
+            <a:r>
+              <a:rPr sz="1300">
+                <a:solidFill>
+                  <a:srgbClr val="58A6FF"/>
+                </a:solidFill>
+                <a:hlinkClick r:id="rId11"/>
+              </a:rPr>
+              <a:t>  Azure — 8 regressions</a:t>
+            </a:r>
+          </a:p>
+          <a:p>
+            <a:pPr>
+              <a:spcAft>
+                <a:spcPts val="300"/>
+              </a:spcAft>
+            </a:pPr>
+            <a:r>
+              <a:rPr sz="1300">
+                <a:solidFill>
+                  <a:srgbClr val="58A6FF"/>
+                </a:solidFill>
+                <a:hlinkClick r:id="rId12"/>
+              </a:rPr>
+              <a:t>  Apex Legends — 8 regressions</a:t>
+            </a:r>
+          </a:p>
+          <a:p>
+            <a:pPr>
+              <a:spcAft>
+                <a:spcPts val="300"/>
+              </a:spcAft>
+            </a:pPr>
+            <a:r>
+              <a:rPr sz="1300">
+                <a:solidFill>
+                  <a:srgbClr val="58A6FF"/>
+                </a:solidFill>
+                <a:hlinkClick r:id="rId13"/>
+              </a:rPr>
+              <a:t>  Mavka — 5 regressions</a:t>
+            </a:r>
+          </a:p>
+          <a:p>
+            <a:pPr>
+              <a:spcAft>
+                <a:spcPts val="300"/>
+              </a:spcAft>
+            </a:pPr>
+            <a:r>
+              <a:rPr sz="1300">
+                <a:solidFill>
+                  <a:srgbClr val="58A6FF"/>
+                </a:solidFill>
+                <a:hlinkClick r:id="rId14"/>
+              </a:rPr>
+              <a:t>  AI Agents — 4 regressions</a:t>
+            </a:r>
+          </a:p>
+          <a:p>
+            <a:pPr>
+              <a:spcAft>
+                <a:spcPts val="300"/>
+              </a:spcAft>
+            </a:pPr>
+            <a:r>
+              <a:rPr sz="1300">
+                <a:solidFill>
+                  <a:srgbClr val="58A6FF"/>
+                </a:solidFill>
+                <a:hlinkClick r:id="rId15"/>
+              </a:rPr>
+              <a:t>  Opus — 4 regressions</a:t>
+            </a:r>
+          </a:p>
+          <a:p>
+            <a:pPr>
+              <a:spcAft>
+                <a:spcPts val="300"/>
+              </a:spcAft>
+            </a:pPr>
+            <a:r>
+              <a:rPr sz="1300">
+                <a:solidFill>
+                  <a:srgbClr val="58A6FF"/>
+                </a:solidFill>
+                <a:hlinkClick r:id="rId16"/>
+              </a:rPr>
+              <a:t>  Cyber Resilience — 1 regression</a:t>
             </a:r>
           </a:p>
         </p:txBody>

</xml_diff>